<commit_message>
Release OneSlide v1.4.0 editorial editor
</commit_message>
<xml_diff>
--- a/builder/assets/test-fixtures/r6-brand-template.pptx
+++ b/builder/assets/test-fixtures/r6-brand-template.pptx
@@ -1034,148 +1034,82 @@
 </file>
 
 <file path=ppt/slides/slide1.xml><?xml version="1.0" encoding="utf-8"?>
-<p:sld xmlns:p="http://schemas.openxmlformats.org/presentationml/2006/main">
-  <p:cSld>
-    <p:bg>
-      <p:bgPr>
-        <a:solidFill xmlns:a="http://schemas.openxmlformats.org/drawingml/2006/main">
-          <a:srgbClr val="FFFFFF"/>
-        </a:solidFill>
-      </p:bgPr>
-    </p:bg>
-    <p:spTree>
-      <p:nvGrpSpPr>
-        <p:cNvPr id="1" name=""/>
-        <p:cNvGrpSpPr/>
-        <p:nvPr/>
-      </p:nvGrpSpPr>
-      <p:grpSpPr>
-        <a:xfrm xmlns:a="http://schemas.openxmlformats.org/drawingml/2006/main"/>
-      </p:grpSpPr>
-      <p:sp>
-        <p:nvSpPr>
-          <p:cNvPr id="4" name="template-top-rule">
-            <a:extLst xmlns:a="http://schemas.openxmlformats.org/drawingml/2006/main">
-              <a:ext uri="{FF2B5EF4-FFF2-40B4-BE49-F238E27FC236}">
-                <a16:creationId xmlns:a16="http://schemas.microsoft.com/office/drawing/2014/main" id="{E63086EA-4A5F-47BB-9B2D-CDEE87A4FE01}"/>
-              </a:ext>
-            </a:extLst>
-          </p:cNvPr>
-          <p:cNvSpPr>
-            <a:spLocks xmlns:a="http://schemas.openxmlformats.org/drawingml/2006/main" noGrp="1"/>
-          </p:cNvSpPr>
-          <p:nvPr/>
-        </p:nvSpPr>
-        <p:spPr>
-          <a:xfrm xmlns:a="http://schemas.openxmlformats.org/drawingml/2006/main">
-            <a:off x="0" y="0"/>
-            <a:ext cx="12192000" cy="57150"/>
-          </a:xfrm>
-          <a:prstGeom xmlns:a="http://schemas.openxmlformats.org/drawingml/2006/main" prst="rect">
-            <a:avLst/>
-          </a:prstGeom>
-          <a:solidFill xmlns:a="http://schemas.openxmlformats.org/drawingml/2006/main">
-            <a:srgbClr val="E8872D"/>
-          </a:solidFill>
-          <a:ln xmlns:a="http://schemas.openxmlformats.org/drawingml/2006/main" w="0">
-            <a:solidFill>
-              <a:srgbClr val="E8872D"/>
-            </a:solidFill>
-            <a:prstDash val="solid"/>
-          </a:ln>
-        </p:spPr>
-      </p:sp>
-      <p:sp>
-        <p:nvSpPr>
-          <p:cNvPr id="2" name="template-bottom-rule">
-            <a:extLst xmlns:a="http://schemas.openxmlformats.org/drawingml/2006/main">
-              <a:ext uri="{FF2B5EF4-FFF2-40B4-BE49-F238E27FC236}">
-                <a16:creationId xmlns:a16="http://schemas.microsoft.com/office/drawing/2014/main" id="{CA5F45BB-97C6-4BF3-9FBF-8834E301F79F}"/>
-              </a:ext>
-            </a:extLst>
-          </p:cNvPr>
-          <p:cNvSpPr>
-            <a:spLocks xmlns:a="http://schemas.openxmlformats.org/drawingml/2006/main" noGrp="1"/>
-          </p:cNvSpPr>
-          <p:nvPr/>
-        </p:nvSpPr>
-        <p:spPr>
-          <a:xfrm xmlns:a="http://schemas.openxmlformats.org/drawingml/2006/main">
-            <a:off x="0" y="6800850"/>
-            <a:ext cx="12192000" cy="57150"/>
-          </a:xfrm>
-          <a:prstGeom xmlns:a="http://schemas.openxmlformats.org/drawingml/2006/main" prst="rect">
-            <a:avLst/>
-          </a:prstGeom>
-          <a:solidFill xmlns:a="http://schemas.openxmlformats.org/drawingml/2006/main">
-            <a:srgbClr val="15375F"/>
-          </a:solidFill>
-          <a:ln xmlns:a="http://schemas.openxmlformats.org/drawingml/2006/main" w="0">
-            <a:solidFill>
-              <a:srgbClr val="15375F"/>
-            </a:solidFill>
-            <a:prstDash val="solid"/>
-          </a:ln>
-        </p:spPr>
-      </p:sp>
-      <p:sp>
-        <p:nvSpPr>
-          <p:cNvPr id="3" name="template-footer">
-            <a:extLst xmlns:a="http://schemas.openxmlformats.org/drawingml/2006/main">
-              <a:ext uri="{FF2B5EF4-FFF2-40B4-BE49-F238E27FC236}">
-                <a16:creationId xmlns:a16="http://schemas.microsoft.com/office/drawing/2014/main" id="{C8395F54-F732-4BC0-B1CD-E729B3E869BB}"/>
-              </a:ext>
-            </a:extLst>
-          </p:cNvPr>
-          <p:cNvSpPr>
-            <a:spLocks xmlns:a="http://schemas.openxmlformats.org/drawingml/2006/main" noGrp="1"/>
-          </p:cNvSpPr>
-          <p:nvPr/>
-        </p:nvSpPr>
-        <p:spPr>
-          <a:xfrm xmlns:a="http://schemas.openxmlformats.org/drawingml/2006/main">
-            <a:off x="9334500" y="6477000"/>
-            <a:ext cx="2476500" cy="228600"/>
-          </a:xfrm>
-          <a:prstGeom xmlns:a="http://schemas.openxmlformats.org/drawingml/2006/main" prst="rect">
-            <a:avLst/>
-          </a:prstGeom>
-          <a:noFill xmlns:a="http://schemas.openxmlformats.org/drawingml/2006/main"/>
-          <a:ln xmlns:a="http://schemas.openxmlformats.org/drawingml/2006/main" w="0">
-            <a:noFill/>
-            <a:prstDash val="solid"/>
-          </a:ln>
-        </p:spPr>
-        <p:txBody>
-          <a:bodyPr xmlns:a="http://schemas.openxmlformats.org/drawingml/2006/main" anchor="ctr"/>
-          <a:lstStyle xmlns:a="http://schemas.openxmlformats.org/drawingml/2006/main"/>
-          <a:p xmlns:a="http://schemas.openxmlformats.org/drawingml/2006/main">
-            <a:pPr algn="r">
-              <a:defRPr sz="1200" b="0">
-                <a:solidFill>
-                  <a:srgbClr val="697386"/>
-                </a:solidFill>
-              </a:defRPr>
-            </a:pPr>
-            <a:r>
-              <a:rPr sz="1200" b="0">
-                <a:solidFill>
-                  <a:srgbClr val="697386"/>
-                </a:solidFill>
-              </a:rPr>
-              <a:t>示例客户模板｜Confidential</a:t>
-            </a:r>
-          </a:p>
-        </p:txBody>
-      </p:sp>
-    </p:spTree>
-    <p:extLst>
-      <p:ext uri="{BB962C8B-B14F-4D97-AF65-F5344CB8AC3E}">
-        <p14:creationId xmlns:p14="http://schemas.microsoft.com/office/powerpoint/2010/main" val="1072006068"/>
-      </p:ext>
-    </p:extLst>
-  </p:cSld>
-</p:sld>
+<ns0:sld xmlns:ns0="http://schemas.openxmlformats.org/presentationml/2006/main" xmlns:ns1="http://schemas.openxmlformats.org/drawingml/2006/main" xmlns:ns2="http://schemas.microsoft.com/office/drawing/2014/main" xmlns:ns3="http://schemas.microsoft.com/office/powerpoint/2010/main">
+  <ns0:cSld>
+    <ns0:bg>
+      <ns0:bgPr>
+        <ns1:solidFill>
+          <ns1:srgbClr val="FFFFFF"/>
+        </ns1:solidFill>
+      </ns0:bgPr>
+    </ns0:bg>
+    <ns0:spTree>
+      <ns0:nvGrpSpPr>
+        <ns0:cNvPr id="1" name=""/>
+        <ns0:cNvGrpSpPr/>
+        <ns0:nvPr/>
+      </ns0:nvGrpSpPr>
+      <ns0:grpSpPr>
+        <ns1:xfrm/>
+      </ns0:grpSpPr>
+      <ns0:sp>
+        <ns0:nvSpPr>
+          <ns0:cNvPr id="3" name="template-footer">
+            <ns1:extLst>
+              <ns1:ext uri="{FF2B5EF4-FFF2-40B4-BE49-F238E27FC236}">
+                <ns2:creationId id="{C8395F54-F732-4BC0-B1CD-E729B3E869BB}"/>
+              </ns1:ext>
+            </ns1:extLst>
+          </ns0:cNvPr>
+          <ns0:cNvSpPr>
+            <ns1:spLocks noGrp="1"/>
+          </ns0:cNvSpPr>
+          <ns0:nvPr/>
+        </ns0:nvSpPr>
+        <ns0:spPr>
+          <ns1:xfrm>
+            <ns1:off x="9334500" y="6477000"/>
+            <ns1:ext cx="2476500" cy="228600"/>
+          </ns1:xfrm>
+          <ns1:prstGeom prst="rect">
+            <ns1:avLst/>
+          </ns1:prstGeom>
+          <ns1:noFill/>
+          <ns1:ln w="0">
+            <ns1:noFill/>
+            <ns1:prstDash val="solid"/>
+          </ns1:ln>
+        </ns0:spPr>
+        <ns0:txBody>
+          <ns1:bodyPr anchor="ctr"/>
+          <ns1:lstStyle/>
+          <ns1:p>
+            <ns1:pPr algn="r">
+              <ns1:defRPr sz="1200" b="0">
+                <ns1:solidFill>
+                  <ns1:srgbClr val="697386"/>
+                </ns1:solidFill>
+              </ns1:defRPr>
+            </ns1:pPr>
+            <ns1:r>
+              <ns1:rPr sz="1200" b="0">
+                <ns1:solidFill>
+                  <ns1:srgbClr val="697386"/>
+                </ns1:solidFill>
+              </ns1:rPr>
+              <ns1:t>示例客户模板｜Confidential</ns1:t>
+            </ns1:r>
+          </ns1:p>
+        </ns0:txBody>
+      </ns0:sp>
+    </ns0:spTree>
+    <ns0:extLst>
+      <ns0:ext uri="{BB962C8B-B14F-4D97-AF65-F5344CB8AC3E}">
+        <ns3:creationId val="1072006068"/>
+      </ns0:ext>
+    </ns0:extLst>
+  </ns0:cSld>
+</ns0:sld>
 </file>
 
 <file path=ppt/theme/theme1.xml><?xml version="1.0" encoding="utf-8"?>

</xml_diff>

<commit_message>
Revert "Merge pull request #2 from marcozhou26/agent/editorial-editor-1-4"
This reverts commit eb01dbc617720dd69edd36d699507dc8768c5347, reversing
changes made to 0b39aef6845bd0f0fb3e92a311d031977ad2becc.
</commit_message>
<xml_diff>
--- a/builder/assets/test-fixtures/r6-brand-template.pptx
+++ b/builder/assets/test-fixtures/r6-brand-template.pptx
@@ -1034,82 +1034,148 @@
 </file>
 
 <file path=ppt/slides/slide1.xml><?xml version="1.0" encoding="utf-8"?>
-<ns0:sld xmlns:ns0="http://schemas.openxmlformats.org/presentationml/2006/main" xmlns:ns1="http://schemas.openxmlformats.org/drawingml/2006/main" xmlns:ns2="http://schemas.microsoft.com/office/drawing/2014/main" xmlns:ns3="http://schemas.microsoft.com/office/powerpoint/2010/main">
-  <ns0:cSld>
-    <ns0:bg>
-      <ns0:bgPr>
-        <ns1:solidFill>
-          <ns1:srgbClr val="FFFFFF"/>
-        </ns1:solidFill>
-      </ns0:bgPr>
-    </ns0:bg>
-    <ns0:spTree>
-      <ns0:nvGrpSpPr>
-        <ns0:cNvPr id="1" name=""/>
-        <ns0:cNvGrpSpPr/>
-        <ns0:nvPr/>
-      </ns0:nvGrpSpPr>
-      <ns0:grpSpPr>
-        <ns1:xfrm/>
-      </ns0:grpSpPr>
-      <ns0:sp>
-        <ns0:nvSpPr>
-          <ns0:cNvPr id="3" name="template-footer">
-            <ns1:extLst>
-              <ns1:ext uri="{FF2B5EF4-FFF2-40B4-BE49-F238E27FC236}">
-                <ns2:creationId id="{C8395F54-F732-4BC0-B1CD-E729B3E869BB}"/>
-              </ns1:ext>
-            </ns1:extLst>
-          </ns0:cNvPr>
-          <ns0:cNvSpPr>
-            <ns1:spLocks noGrp="1"/>
-          </ns0:cNvSpPr>
-          <ns0:nvPr/>
-        </ns0:nvSpPr>
-        <ns0:spPr>
-          <ns1:xfrm>
-            <ns1:off x="9334500" y="6477000"/>
-            <ns1:ext cx="2476500" cy="228600"/>
-          </ns1:xfrm>
-          <ns1:prstGeom prst="rect">
-            <ns1:avLst/>
-          </ns1:prstGeom>
-          <ns1:noFill/>
-          <ns1:ln w="0">
-            <ns1:noFill/>
-            <ns1:prstDash val="solid"/>
-          </ns1:ln>
-        </ns0:spPr>
-        <ns0:txBody>
-          <ns1:bodyPr anchor="ctr"/>
-          <ns1:lstStyle/>
-          <ns1:p>
-            <ns1:pPr algn="r">
-              <ns1:defRPr sz="1200" b="0">
-                <ns1:solidFill>
-                  <ns1:srgbClr val="697386"/>
-                </ns1:solidFill>
-              </ns1:defRPr>
-            </ns1:pPr>
-            <ns1:r>
-              <ns1:rPr sz="1200" b="0">
-                <ns1:solidFill>
-                  <ns1:srgbClr val="697386"/>
-                </ns1:solidFill>
-              </ns1:rPr>
-              <ns1:t>示例客户模板｜Confidential</ns1:t>
-            </ns1:r>
-          </ns1:p>
-        </ns0:txBody>
-      </ns0:sp>
-    </ns0:spTree>
-    <ns0:extLst>
-      <ns0:ext uri="{BB962C8B-B14F-4D97-AF65-F5344CB8AC3E}">
-        <ns3:creationId val="1072006068"/>
-      </ns0:ext>
-    </ns0:extLst>
-  </ns0:cSld>
-</ns0:sld>
+<p:sld xmlns:p="http://schemas.openxmlformats.org/presentationml/2006/main">
+  <p:cSld>
+    <p:bg>
+      <p:bgPr>
+        <a:solidFill xmlns:a="http://schemas.openxmlformats.org/drawingml/2006/main">
+          <a:srgbClr val="FFFFFF"/>
+        </a:solidFill>
+      </p:bgPr>
+    </p:bg>
+    <p:spTree>
+      <p:nvGrpSpPr>
+        <p:cNvPr id="1" name=""/>
+        <p:cNvGrpSpPr/>
+        <p:nvPr/>
+      </p:nvGrpSpPr>
+      <p:grpSpPr>
+        <a:xfrm xmlns:a="http://schemas.openxmlformats.org/drawingml/2006/main"/>
+      </p:grpSpPr>
+      <p:sp>
+        <p:nvSpPr>
+          <p:cNvPr id="4" name="template-top-rule">
+            <a:extLst xmlns:a="http://schemas.openxmlformats.org/drawingml/2006/main">
+              <a:ext uri="{FF2B5EF4-FFF2-40B4-BE49-F238E27FC236}">
+                <a16:creationId xmlns:a16="http://schemas.microsoft.com/office/drawing/2014/main" id="{E63086EA-4A5F-47BB-9B2D-CDEE87A4FE01}"/>
+              </a:ext>
+            </a:extLst>
+          </p:cNvPr>
+          <p:cNvSpPr>
+            <a:spLocks xmlns:a="http://schemas.openxmlformats.org/drawingml/2006/main" noGrp="1"/>
+          </p:cNvSpPr>
+          <p:nvPr/>
+        </p:nvSpPr>
+        <p:spPr>
+          <a:xfrm xmlns:a="http://schemas.openxmlformats.org/drawingml/2006/main">
+            <a:off x="0" y="0"/>
+            <a:ext cx="12192000" cy="57150"/>
+          </a:xfrm>
+          <a:prstGeom xmlns:a="http://schemas.openxmlformats.org/drawingml/2006/main" prst="rect">
+            <a:avLst/>
+          </a:prstGeom>
+          <a:solidFill xmlns:a="http://schemas.openxmlformats.org/drawingml/2006/main">
+            <a:srgbClr val="E8872D"/>
+          </a:solidFill>
+          <a:ln xmlns:a="http://schemas.openxmlformats.org/drawingml/2006/main" w="0">
+            <a:solidFill>
+              <a:srgbClr val="E8872D"/>
+            </a:solidFill>
+            <a:prstDash val="solid"/>
+          </a:ln>
+        </p:spPr>
+      </p:sp>
+      <p:sp>
+        <p:nvSpPr>
+          <p:cNvPr id="2" name="template-bottom-rule">
+            <a:extLst xmlns:a="http://schemas.openxmlformats.org/drawingml/2006/main">
+              <a:ext uri="{FF2B5EF4-FFF2-40B4-BE49-F238E27FC236}">
+                <a16:creationId xmlns:a16="http://schemas.microsoft.com/office/drawing/2014/main" id="{CA5F45BB-97C6-4BF3-9FBF-8834E301F79F}"/>
+              </a:ext>
+            </a:extLst>
+          </p:cNvPr>
+          <p:cNvSpPr>
+            <a:spLocks xmlns:a="http://schemas.openxmlformats.org/drawingml/2006/main" noGrp="1"/>
+          </p:cNvSpPr>
+          <p:nvPr/>
+        </p:nvSpPr>
+        <p:spPr>
+          <a:xfrm xmlns:a="http://schemas.openxmlformats.org/drawingml/2006/main">
+            <a:off x="0" y="6800850"/>
+            <a:ext cx="12192000" cy="57150"/>
+          </a:xfrm>
+          <a:prstGeom xmlns:a="http://schemas.openxmlformats.org/drawingml/2006/main" prst="rect">
+            <a:avLst/>
+          </a:prstGeom>
+          <a:solidFill xmlns:a="http://schemas.openxmlformats.org/drawingml/2006/main">
+            <a:srgbClr val="15375F"/>
+          </a:solidFill>
+          <a:ln xmlns:a="http://schemas.openxmlformats.org/drawingml/2006/main" w="0">
+            <a:solidFill>
+              <a:srgbClr val="15375F"/>
+            </a:solidFill>
+            <a:prstDash val="solid"/>
+          </a:ln>
+        </p:spPr>
+      </p:sp>
+      <p:sp>
+        <p:nvSpPr>
+          <p:cNvPr id="3" name="template-footer">
+            <a:extLst xmlns:a="http://schemas.openxmlformats.org/drawingml/2006/main">
+              <a:ext uri="{FF2B5EF4-FFF2-40B4-BE49-F238E27FC236}">
+                <a16:creationId xmlns:a16="http://schemas.microsoft.com/office/drawing/2014/main" id="{C8395F54-F732-4BC0-B1CD-E729B3E869BB}"/>
+              </a:ext>
+            </a:extLst>
+          </p:cNvPr>
+          <p:cNvSpPr>
+            <a:spLocks xmlns:a="http://schemas.openxmlformats.org/drawingml/2006/main" noGrp="1"/>
+          </p:cNvSpPr>
+          <p:nvPr/>
+        </p:nvSpPr>
+        <p:spPr>
+          <a:xfrm xmlns:a="http://schemas.openxmlformats.org/drawingml/2006/main">
+            <a:off x="9334500" y="6477000"/>
+            <a:ext cx="2476500" cy="228600"/>
+          </a:xfrm>
+          <a:prstGeom xmlns:a="http://schemas.openxmlformats.org/drawingml/2006/main" prst="rect">
+            <a:avLst/>
+          </a:prstGeom>
+          <a:noFill xmlns:a="http://schemas.openxmlformats.org/drawingml/2006/main"/>
+          <a:ln xmlns:a="http://schemas.openxmlformats.org/drawingml/2006/main" w="0">
+            <a:noFill/>
+            <a:prstDash val="solid"/>
+          </a:ln>
+        </p:spPr>
+        <p:txBody>
+          <a:bodyPr xmlns:a="http://schemas.openxmlformats.org/drawingml/2006/main" anchor="ctr"/>
+          <a:lstStyle xmlns:a="http://schemas.openxmlformats.org/drawingml/2006/main"/>
+          <a:p xmlns:a="http://schemas.openxmlformats.org/drawingml/2006/main">
+            <a:pPr algn="r">
+              <a:defRPr sz="1200" b="0">
+                <a:solidFill>
+                  <a:srgbClr val="697386"/>
+                </a:solidFill>
+              </a:defRPr>
+            </a:pPr>
+            <a:r>
+              <a:rPr sz="1200" b="0">
+                <a:solidFill>
+                  <a:srgbClr val="697386"/>
+                </a:solidFill>
+              </a:rPr>
+              <a:t>示例客户模板｜Confidential</a:t>
+            </a:r>
+          </a:p>
+        </p:txBody>
+      </p:sp>
+    </p:spTree>
+    <p:extLst>
+      <p:ext uri="{BB962C8B-B14F-4D97-AF65-F5344CB8AC3E}">
+        <p14:creationId xmlns:p14="http://schemas.microsoft.com/office/powerpoint/2010/main" val="1072006068"/>
+      </p:ext>
+    </p:extLst>
+  </p:cSld>
+</p:sld>
 </file>
 
 <file path=ppt/theme/theme1.xml><?xml version="1.0" encoding="utf-8"?>

</xml_diff>